<commit_message>
1st Sem : After NN - Exam Board Midterm and preboard Questions Update 2025-06-29 22:29:44
</commit_message>
<xml_diff>
--- a/Main/Study/First Sem/All Notes and Resources Combined/NN Notes/Unit -1 Introduction to ANN.pptx
+++ b/Main/Study/First Sem/All Notes and Resources Combined/NN Notes/Unit -1 Introduction to ANN.pptx
@@ -175,6 +175,30 @@
 
 <file path=ppt/changesInfos/changesInfo1.xml><?xml version="1.0" encoding="utf-8"?>
 <pc:chgInfo xmlns:a="http://schemas.openxmlformats.org/drawingml/2006/main" xmlns:r="http://schemas.openxmlformats.org/officeDocument/2006/relationships" xmlns:ac="http://schemas.microsoft.com/office/drawing/2013/main/command" xmlns:pc="http://schemas.microsoft.com/office/powerpoint/2013/main/command">
+  <pc:docChgLst>
+    <pc:chgData name="Yujan Basnet" userId="495fd8277ebfbaef" providerId="LiveId" clId="{CF25E929-184C-4165-99ED-8AD243A75CA4}"/>
+    <pc:docChg chg="modSld">
+      <pc:chgData name="Yujan Basnet" userId="495fd8277ebfbaef" providerId="LiveId" clId="{CF25E929-184C-4165-99ED-8AD243A75CA4}" dt="2025-06-28T12:14:58.745" v="0" actId="207"/>
+      <pc:docMkLst>
+        <pc:docMk/>
+      </pc:docMkLst>
+      <pc:sldChg chg="modSp mod">
+        <pc:chgData name="Yujan Basnet" userId="495fd8277ebfbaef" providerId="LiveId" clId="{CF25E929-184C-4165-99ED-8AD243A75CA4}" dt="2025-06-28T12:14:58.745" v="0" actId="207"/>
+        <pc:sldMkLst>
+          <pc:docMk/>
+          <pc:sldMk cId="2317034463" sldId="425"/>
+        </pc:sldMkLst>
+        <pc:spChg chg="mod">
+          <ac:chgData name="Yujan Basnet" userId="495fd8277ebfbaef" providerId="LiveId" clId="{CF25E929-184C-4165-99ED-8AD243A75CA4}" dt="2025-06-28T12:14:58.745" v="0" actId="207"/>
+          <ac:spMkLst>
+            <pc:docMk/>
+            <pc:sldMk cId="2317034463" sldId="425"/>
+            <ac:spMk id="9" creationId="{00000000-0000-0000-0000-000000000000}"/>
+          </ac:spMkLst>
+        </pc:spChg>
+      </pc:sldChg>
+    </pc:docChg>
+  </pc:docChgLst>
   <pc:docChgLst>
     <pc:chgData name="Yujan Basnet" userId="495fd8277ebfbaef" providerId="LiveId" clId="{336517B1-8863-409E-90DF-8193AB82D4A7}"/>
     <pc:docChg chg="modSld">
@@ -630,7 +654,7 @@
             <a:fld id="{226EBE57-06B5-493A-882E-E27946C0749C}" type="datetimeFigureOut">
               <a:rPr lang="en-US" smtClean="0"/>
               <a:pPr/>
-              <a:t>6/3/2025</a:t>
+              <a:t>6/28/2025</a:t>
             </a:fld>
             <a:endParaRPr lang="en-US"/>
           </a:p>
@@ -1164,7 +1188,7 @@
           <a:p>
             <a:fld id="{60973A45-E808-4DE1-B5F5-5C474A96C3AF}" type="datetime1">
               <a:rPr lang="en-US" smtClean="0"/>
-              <a:t>6/3/2025</a:t>
+              <a:t>6/28/2025</a:t>
             </a:fld>
             <a:endParaRPr lang="en-US"/>
           </a:p>
@@ -1332,7 +1356,7 @@
           <a:p>
             <a:fld id="{5E5252F6-ABD8-458E-8EA7-0DD4FE700704}" type="datetime1">
               <a:rPr lang="en-US" smtClean="0"/>
-              <a:t>6/3/2025</a:t>
+              <a:t>6/28/2025</a:t>
             </a:fld>
             <a:endParaRPr lang="en-US"/>
           </a:p>
@@ -1510,7 +1534,7 @@
           <a:p>
             <a:fld id="{7BFBFB6F-5DD8-444A-BDEF-1B92E2203776}" type="datetime1">
               <a:rPr lang="en-US" smtClean="0"/>
-              <a:t>6/3/2025</a:t>
+              <a:t>6/28/2025</a:t>
             </a:fld>
             <a:endParaRPr lang="en-US"/>
           </a:p>
@@ -1678,7 +1702,7 @@
           <a:p>
             <a:fld id="{DCED0CC9-D3BB-411A-A928-EEDC6ACC32EA}" type="datetime1">
               <a:rPr lang="en-US" smtClean="0"/>
-              <a:t>6/3/2025</a:t>
+              <a:t>6/28/2025</a:t>
             </a:fld>
             <a:endParaRPr lang="en-US"/>
           </a:p>
@@ -1923,7 +1947,7 @@
           <a:p>
             <a:fld id="{4AC85315-E6F0-43E1-8D75-22B2F33F2E50}" type="datetime1">
               <a:rPr lang="en-US" smtClean="0"/>
-              <a:t>6/3/2025</a:t>
+              <a:t>6/28/2025</a:t>
             </a:fld>
             <a:endParaRPr lang="en-US"/>
           </a:p>
@@ -2208,7 +2232,7 @@
           <a:p>
             <a:fld id="{36BEE8EF-B5D5-4C89-B4F6-E2A9E7D54FD5}" type="datetime1">
               <a:rPr lang="en-US" smtClean="0"/>
-              <a:t>6/3/2025</a:t>
+              <a:t>6/28/2025</a:t>
             </a:fld>
             <a:endParaRPr lang="en-US"/>
           </a:p>
@@ -2627,7 +2651,7 @@
           <a:p>
             <a:fld id="{54A31B42-D524-434E-90CE-74FA6F624DA7}" type="datetime1">
               <a:rPr lang="en-US" smtClean="0"/>
-              <a:t>6/3/2025</a:t>
+              <a:t>6/28/2025</a:t>
             </a:fld>
             <a:endParaRPr lang="en-US"/>
           </a:p>
@@ -2744,7 +2768,7 @@
           <a:p>
             <a:fld id="{B8A12CBF-1D4B-447D-95C5-3E69D9EDDF94}" type="datetime1">
               <a:rPr lang="en-US" smtClean="0"/>
-              <a:t>6/3/2025</a:t>
+              <a:t>6/28/2025</a:t>
             </a:fld>
             <a:endParaRPr lang="en-US"/>
           </a:p>
@@ -2839,7 +2863,7 @@
           <a:p>
             <a:fld id="{C951663F-CFD7-4A29-9E7C-FEA62B0F3FF4}" type="datetime1">
               <a:rPr lang="en-US" smtClean="0"/>
-              <a:t>6/3/2025</a:t>
+              <a:t>6/28/2025</a:t>
             </a:fld>
             <a:endParaRPr lang="en-US"/>
           </a:p>
@@ -3114,7 +3138,7 @@
           <a:p>
             <a:fld id="{8A4DC412-ECFC-4DE3-9D2E-55184920634B}" type="datetime1">
               <a:rPr lang="en-US" smtClean="0"/>
-              <a:t>6/3/2025</a:t>
+              <a:t>6/28/2025</a:t>
             </a:fld>
             <a:endParaRPr lang="en-US"/>
           </a:p>
@@ -3366,7 +3390,7 @@
           <a:p>
             <a:fld id="{A3C72E79-9B25-44C7-BBAB-7D259F23E352}" type="datetime1">
               <a:rPr lang="en-US" smtClean="0"/>
-              <a:t>6/3/2025</a:t>
+              <a:t>6/28/2025</a:t>
             </a:fld>
             <a:endParaRPr lang="en-US"/>
           </a:p>
@@ -3577,7 +3601,7 @@
           <a:p>
             <a:fld id="{54D4AFE3-6763-450B-8B86-061CCC9B9A00}" type="datetime1">
               <a:rPr lang="en-US" smtClean="0"/>
-              <a:t>6/3/2025</a:t>
+              <a:t>6/28/2025</a:t>
             </a:fld>
             <a:endParaRPr lang="en-US"/>
           </a:p>
@@ -4256,7 +4280,7 @@
           <a:p>
             <a:pPr lvl="1" algn="just"/>
             <a:endParaRPr lang="en-US" sz="2400" dirty="0">
-              <a:latin typeface="Book Antiqua" pitchFamily="18" charset="0"/>
+              <a:latin typeface="Book Antiqua" panose="02040602050305030304" pitchFamily="18" charset="0"/>
             </a:endParaRPr>
           </a:p>
         </p:txBody>
@@ -15226,7 +15250,22 @@
               <a:rPr lang="en-US" sz="2600" dirty="0">
                 <a:latin typeface="Book Antiqua" pitchFamily="18" charset="0"/>
               </a:rPr>
-              <a:t>Softmax is fundamentally a vector function. It takes a vector as input and produces a vector as output.</a:t>
+              <a:t>Softmax is fundamentally a </a:t>
+            </a:r>
+            <a:r>
+              <a:rPr lang="en-US" sz="2600" dirty="0">
+                <a:solidFill>
+                  <a:srgbClr val="FF0000"/>
+                </a:solidFill>
+                <a:latin typeface="Book Antiqua" pitchFamily="18" charset="0"/>
+              </a:rPr>
+              <a:t>vector function. </a:t>
+            </a:r>
+            <a:r>
+              <a:rPr lang="en-US" sz="2600" dirty="0">
+                <a:latin typeface="Book Antiqua" pitchFamily="18" charset="0"/>
+              </a:rPr>
+              <a:t>It takes a vector as input and produces a vector as output.</a:t>
             </a:r>
           </a:p>
           <a:p>
@@ -20531,7 +20570,7 @@
           <a:p>
             <a:pPr algn="just"/>
             <a:endParaRPr lang="en-US" sz="2400" dirty="0">
-              <a:latin typeface="Book Antiqua" pitchFamily="18" charset="0"/>
+              <a:latin typeface="Book Antiqua" panose="02040602050305030304" pitchFamily="18" charset="0"/>
             </a:endParaRPr>
           </a:p>
         </p:txBody>

</xml_diff>